<commit_message>
Update lecture files for Ch 7-9 and IT-612
Add accessible PDFs for CSC 621 lectures: Ch-07 and Ch-08. Replace/update binary lecture assets: Ch-08 PPTX and Ch-09 PDF in CSC 621, and update Chapter-05 PDF for IT 612 (IT Project Management).
</commit_message>
<xml_diff>
--- a/Chapter Two 1447/CSC 621 Research Methods/Lectures/Ch-08-PPTaccessible.pptx
+++ b/Chapter Two 1447/CSC 621 Research Methods/Lectures/Ch-08-PPTaccessible.pptx
@@ -2,45 +2,45 @@
 <file path=ppt/presentation.xml><?xml version="1.0" encoding="utf-8"?>
 <p:presentation xmlns:a="http://schemas.openxmlformats.org/drawingml/2006/main" xmlns:r="http://schemas.openxmlformats.org/officeDocument/2006/relationships" xmlns:p="http://schemas.openxmlformats.org/presentationml/2006/main" strictFirstAndLastChars="0" saveSubsetFonts="1" autoCompressPictures="0">
   <p:sldMasterIdLst>
-    <p:sldMasterId id="2147483659" r:id="rId1"/>
-    <p:sldMasterId id="2147483660" r:id="rId2"/>
+    <p:sldMasterId id="2147483659" r:id="rId4"/>
+    <p:sldMasterId id="2147483660" r:id="rId5"/>
   </p:sldMasterIdLst>
   <p:notesMasterIdLst>
-    <p:notesMasterId r:id="rId32"/>
+    <p:notesMasterId r:id="rId35"/>
   </p:notesMasterIdLst>
   <p:handoutMasterIdLst>
-    <p:handoutMasterId r:id="rId33"/>
+    <p:handoutMasterId r:id="rId36"/>
   </p:handoutMasterIdLst>
   <p:sldIdLst>
-    <p:sldId id="335" r:id="rId3"/>
-    <p:sldId id="307" r:id="rId4"/>
-    <p:sldId id="308" r:id="rId5"/>
-    <p:sldId id="310" r:id="rId6"/>
-    <p:sldId id="311" r:id="rId7"/>
-    <p:sldId id="312" r:id="rId8"/>
-    <p:sldId id="336" r:id="rId9"/>
-    <p:sldId id="313" r:id="rId10"/>
-    <p:sldId id="337" r:id="rId11"/>
-    <p:sldId id="314" r:id="rId12"/>
-    <p:sldId id="315" r:id="rId13"/>
-    <p:sldId id="316" r:id="rId14"/>
-    <p:sldId id="317" r:id="rId15"/>
-    <p:sldId id="318" r:id="rId16"/>
-    <p:sldId id="338" r:id="rId17"/>
-    <p:sldId id="319" r:id="rId18"/>
-    <p:sldId id="320" r:id="rId19"/>
-    <p:sldId id="321" r:id="rId20"/>
-    <p:sldId id="339" r:id="rId21"/>
-    <p:sldId id="340" r:id="rId22"/>
-    <p:sldId id="322" r:id="rId23"/>
-    <p:sldId id="323" r:id="rId24"/>
-    <p:sldId id="341" r:id="rId25"/>
-    <p:sldId id="342" r:id="rId26"/>
-    <p:sldId id="324" r:id="rId27"/>
-    <p:sldId id="346" r:id="rId28"/>
-    <p:sldId id="347" r:id="rId29"/>
-    <p:sldId id="348" r:id="rId30"/>
-    <p:sldId id="334" r:id="rId31"/>
+    <p:sldId id="335" r:id="rId6"/>
+    <p:sldId id="307" r:id="rId7"/>
+    <p:sldId id="308" r:id="rId8"/>
+    <p:sldId id="310" r:id="rId9"/>
+    <p:sldId id="311" r:id="rId10"/>
+    <p:sldId id="312" r:id="rId11"/>
+    <p:sldId id="336" r:id="rId12"/>
+    <p:sldId id="313" r:id="rId13"/>
+    <p:sldId id="337" r:id="rId14"/>
+    <p:sldId id="314" r:id="rId15"/>
+    <p:sldId id="315" r:id="rId16"/>
+    <p:sldId id="316" r:id="rId17"/>
+    <p:sldId id="317" r:id="rId18"/>
+    <p:sldId id="318" r:id="rId19"/>
+    <p:sldId id="338" r:id="rId20"/>
+    <p:sldId id="319" r:id="rId21"/>
+    <p:sldId id="320" r:id="rId22"/>
+    <p:sldId id="321" r:id="rId23"/>
+    <p:sldId id="339" r:id="rId24"/>
+    <p:sldId id="340" r:id="rId25"/>
+    <p:sldId id="322" r:id="rId26"/>
+    <p:sldId id="323" r:id="rId27"/>
+    <p:sldId id="341" r:id="rId28"/>
+    <p:sldId id="342" r:id="rId29"/>
+    <p:sldId id="324" r:id="rId30"/>
+    <p:sldId id="346" r:id="rId31"/>
+    <p:sldId id="347" r:id="rId32"/>
+    <p:sldId id="348" r:id="rId33"/>
+    <p:sldId id="334" r:id="rId34"/>
   </p:sldIdLst>
   <p:sldSz cx="9144000" cy="6858000" type="screen4x3"/>
   <p:notesSz cx="6858000" cy="9144000"/>
@@ -383,7 +383,7 @@
           <a:p>
             <a:fld id="{2885CB01-6679-D646-ACB3-8B04B786C15F}" type="datetimeFigureOut">
               <a:rPr lang="en-US" smtClean="0"/>
-              <a:t>10/22/2021</a:t>
+              <a:t>6/1/2026</a:t>
             </a:fld>
             <a:endParaRPr lang="en-US"/>
           </a:p>
@@ -17101,8 +17101,8 @@
         </p:nvSpPr>
         <p:spPr>
           <a:xfrm>
-            <a:off x="457200" y="303075"/>
-            <a:ext cx="8229600" cy="1144347"/>
+            <a:off x="457200" y="980183"/>
+            <a:ext cx="8229600" cy="467239"/>
           </a:xfrm>
         </p:spPr>
         <p:txBody>
@@ -17118,13 +17118,13 @@
               <a:buClrTx/>
             </a:pPr>
             <a:r>
-              <a:rPr lang="en-US" sz="3600" kern="1200" dirty="0">
+              <a:rPr lang="en-US" sz="2800" kern="1200" dirty="0">
                 <a:latin typeface="+mj-lt"/>
                 <a:cs typeface="Times New Roman" panose="02020603050405020304" pitchFamily="18" charset="0"/>
               </a:rPr>
               <a:t>Strategies to Enhance Credibility and Reliability</a:t>
             </a:r>
-            <a:endParaRPr lang="en-US" altLang="en-US" sz="3600" kern="1200" dirty="0">
+            <a:endParaRPr lang="en-US" altLang="en-US" sz="2800" kern="1200" dirty="0">
               <a:latin typeface="+mj-lt"/>
               <a:ea typeface="+mj-ea"/>
               <a:cs typeface="Times New Roman" panose="02020603050405020304" pitchFamily="18" charset="0"/>
@@ -17721,7 +17721,7 @@
         <p:spPr>
           <a:xfrm>
             <a:off x="436652" y="301888"/>
-            <a:ext cx="8275548" cy="1144347"/>
+            <a:ext cx="8275548" cy="467239"/>
           </a:xfrm>
         </p:spPr>
         <p:txBody>
@@ -17737,13 +17737,13 @@
               <a:buClrTx/>
             </a:pPr>
             <a:r>
-              <a:rPr lang="en-US" altLang="en-US" sz="3600" kern="1200" dirty="0">
+              <a:rPr lang="en-US" altLang="en-US" sz="2800" kern="1200" dirty="0">
                 <a:latin typeface="+mj-lt"/>
                 <a:cs typeface="Times New Roman" panose="02020603050405020304" pitchFamily="18" charset="0"/>
               </a:rPr>
               <a:t>Potential Advantages of Qualitative Research</a:t>
             </a:r>
-            <a:endParaRPr lang="en-US" sz="2800" kern="1200" dirty="0">
+            <a:endParaRPr lang="en-US" sz="2000" kern="1200" dirty="0">
               <a:latin typeface="+mj-lt"/>
               <a:ea typeface="+mj-ea"/>
               <a:cs typeface="Times New Roman" panose="02020603050405020304" pitchFamily="18" charset="0"/>
@@ -18860,8 +18860,8 @@
         </p:nvSpPr>
         <p:spPr>
           <a:xfrm>
-            <a:off x="457200" y="285266"/>
-            <a:ext cx="8229600" cy="1144347"/>
+            <a:off x="457200" y="408376"/>
+            <a:ext cx="8229600" cy="1021237"/>
           </a:xfrm>
         </p:spPr>
         <p:txBody>
@@ -18877,20 +18877,20 @@
               <a:buClrTx/>
             </a:pPr>
             <a:r>
-              <a:rPr lang="en-US" sz="3600" kern="1200">
+              <a:rPr lang="en-US" sz="3200" kern="1200" dirty="0">
                 <a:latin typeface="+mj-lt"/>
                 <a:cs typeface="Times New Roman" panose="02020603050405020304" pitchFamily="18" charset="0"/>
               </a:rPr>
               <a:t>Criteria for Evaluating Qualitative Research</a:t>
             </a:r>
             <a:r>
-              <a:rPr lang="en-US" sz="2800" kern="1200">
+              <a:rPr lang="en-US" sz="2400" kern="1200" dirty="0">
                 <a:latin typeface="+mj-lt"/>
                 <a:cs typeface="Times New Roman" panose="02020603050405020304" pitchFamily="18" charset="0"/>
               </a:rPr>
               <a:t> (1 of 4)</a:t>
             </a:r>
-            <a:endParaRPr lang="en-US" altLang="en-US" sz="2800" kern="1200">
+            <a:endParaRPr lang="en-US" altLang="en-US" sz="2400" kern="1200" dirty="0">
               <a:latin typeface="+mj-lt"/>
               <a:ea typeface="+mj-ea"/>
               <a:cs typeface="Times New Roman" panose="02020603050405020304" pitchFamily="18" charset="0"/>
@@ -22528,6 +22528,21 @@
 </file>
 
 <file path=customXml/item1.xml><?xml version="1.0" encoding="utf-8"?>
+<p:properties xmlns:p="http://schemas.microsoft.com/office/2006/metadata/properties" xmlns:xsi="http://www.w3.org/2001/XMLSchema-instance" xmlns:pc="http://schemas.microsoft.com/office/infopath/2007/PartnerControls">
+  <documentManagement/>
+</p:properties>
+</file>
+
+<file path=customXml/item2.xml><?xml version="1.0" encoding="utf-8"?>
+<?mso-contentType ?>
+<FormTemplates xmlns="http://schemas.microsoft.com/sharepoint/v3/contenttype/forms">
+  <Display>DocumentLibraryForm</Display>
+  <Edit>DocumentLibraryForm</Edit>
+  <New>DocumentLibraryForm</New>
+</FormTemplates>
+</file>
+
+<file path=customXml/item3.xml><?xml version="1.0" encoding="utf-8"?>
 <ct:contentTypeSchema xmlns:ct="http://schemas.microsoft.com/office/2006/metadata/contentType" xmlns:ma="http://schemas.microsoft.com/office/2006/metadata/properties/metaAttributes" ct:_="" ma:_="" ma:contentTypeName="Document" ma:contentTypeID="0x01010086D90B95B22DD945BDFF45EB84A5E21C" ma:contentTypeVersion="12" ma:contentTypeDescription="Create a new document." ma:contentTypeScope="" ma:versionID="9ee3781bcb6633d132c89161492bb118">
   <xsd:schema xmlns:xsd="http://www.w3.org/2001/XMLSchema" xmlns:xs="http://www.w3.org/2001/XMLSchema" xmlns:p="http://schemas.microsoft.com/office/2006/metadata/properties" xmlns:ns2="7c1bd8dc-4e40-424f-a15f-9ffcd522197f" xmlns:ns3="6125ffc9-2c56-435e-8267-1393444907b2" targetNamespace="http://schemas.microsoft.com/office/2006/metadata/properties" ma:root="true" ma:fieldsID="d3e430f46b92204fb5a3381a429c4dbe" ns2:_="" ns3:_="">
     <xsd:import namespace="7c1bd8dc-4e40-424f-a15f-9ffcd522197f"/>
@@ -22744,29 +22759,38 @@
 </ct:contentTypeSchema>
 </file>
 
-<file path=customXml/item2.xml><?xml version="1.0" encoding="utf-8"?>
-<?mso-contentType ?>
-<FormTemplates xmlns="http://schemas.microsoft.com/sharepoint/v3/contenttype/forms">
-  <Display>DocumentLibraryForm</Display>
-  <Edit>DocumentLibraryForm</Edit>
-  <New>DocumentLibraryForm</New>
-</FormTemplates>
-</file>
-
-<file path=customXml/item3.xml><?xml version="1.0" encoding="utf-8"?>
-<p:properties xmlns:p="http://schemas.microsoft.com/office/2006/metadata/properties" xmlns:xsi="http://www.w3.org/2001/XMLSchema-instance" xmlns:pc="http://schemas.microsoft.com/office/infopath/2007/PartnerControls">
-  <documentManagement/>
-</p:properties>
-</file>
-
 <file path=customXml/itemProps1.xml><?xml version="1.0" encoding="utf-8"?>
-<ds:datastoreItem xmlns:ds="http://schemas.openxmlformats.org/officeDocument/2006/customXml" ds:itemID="{9FAE25CD-5C17-4317-A187-ABC2D97383E7}"/>
+<ds:datastoreItem xmlns:ds="http://schemas.openxmlformats.org/officeDocument/2006/customXml" ds:itemID="{44B7347B-018C-4023-8B09-98BAF0B15496}">
+  <ds:schemaRefs>
+    <ds:schemaRef ds:uri="http://schemas.microsoft.com/office/2006/metadata/properties"/>
+    <ds:schemaRef ds:uri="http://schemas.microsoft.com/office/infopath/2007/PartnerControls"/>
+  </ds:schemaRefs>
+</ds:datastoreItem>
 </file>
 
 <file path=customXml/itemProps2.xml><?xml version="1.0" encoding="utf-8"?>
-<ds:datastoreItem xmlns:ds="http://schemas.openxmlformats.org/officeDocument/2006/customXml" ds:itemID="{BE75088A-D0AC-4BE4-81EA-89238BFA139C}"/>
+<ds:datastoreItem xmlns:ds="http://schemas.openxmlformats.org/officeDocument/2006/customXml" ds:itemID="{BE75088A-D0AC-4BE4-81EA-89238BFA139C}">
+  <ds:schemaRefs>
+    <ds:schemaRef ds:uri="http://schemas.microsoft.com/sharepoint/v3/contenttype/forms"/>
+  </ds:schemaRefs>
+</ds:datastoreItem>
 </file>
 
 <file path=customXml/itemProps3.xml><?xml version="1.0" encoding="utf-8"?>
-<ds:datastoreItem xmlns:ds="http://schemas.openxmlformats.org/officeDocument/2006/customXml" ds:itemID="{44B7347B-018C-4023-8B09-98BAF0B15496}"/>
+<ds:datastoreItem xmlns:ds="http://schemas.openxmlformats.org/officeDocument/2006/customXml" ds:itemID="{9FAE25CD-5C17-4317-A187-ABC2D97383E7}">
+  <ds:schemaRefs>
+    <ds:schemaRef ds:uri="http://schemas.microsoft.com/office/2006/metadata/contentType"/>
+    <ds:schemaRef ds:uri="http://schemas.microsoft.com/office/2006/metadata/properties/metaAttributes"/>
+    <ds:schemaRef ds:uri="http://www.w3.org/2001/XMLSchema"/>
+    <ds:schemaRef ds:uri="http://schemas.microsoft.com/office/2006/metadata/properties"/>
+    <ds:schemaRef ds:uri="7c1bd8dc-4e40-424f-a15f-9ffcd522197f"/>
+    <ds:schemaRef ds:uri="6125ffc9-2c56-435e-8267-1393444907b2"/>
+    <ds:schemaRef ds:uri="http://schemas.microsoft.com/office/2006/documentManagement/types"/>
+    <ds:schemaRef ds:uri="http://schemas.microsoft.com/office/infopath/2007/PartnerControls"/>
+    <ds:schemaRef ds:uri="http://schemas.openxmlformats.org/package/2006/metadata/core-properties"/>
+    <ds:schemaRef ds:uri="http://purl.org/dc/elements/1.1/"/>
+    <ds:schemaRef ds:uri="http://purl.org/dc/terms/"/>
+    <ds:schemaRef ds:uri="http://schemas.microsoft.com/internal/obd"/>
+  </ds:schemaRefs>
+</ds:datastoreItem>
 </file>
</xml_diff>